<commit_message>
Generate fully compatible PPTX and vector PDF deliverables with native slide backgrounds and zero member emails
</commit_message>
<xml_diff>
--- a/docs/PRANA_TWIN_Architecture_Diagram.pptx
+++ b/docs/PRANA_TWIN_Architecture_Diagram.pptx
@@ -3081,6 +3081,14 @@
 <file path=ppt/slides/slide1.xml><?xml version="1.0" encoding="utf-8"?>
 <p:sld xmlns:a="http://schemas.openxmlformats.org/drawingml/2006/main" xmlns:p="http://schemas.openxmlformats.org/presentationml/2006/main" xmlns:r="http://schemas.openxmlformats.org/officeDocument/2006/relationships">
   <p:cSld>
+    <p:bg>
+      <p:bgPr>
+        <a:solidFill>
+          <a:srgbClr val="0A0F1D"/>
+        </a:solidFill>
+        <a:effectLst/>
+      </p:bgPr>
+    </p:bg>
     <p:spTree>
       <p:nvGrpSpPr>
         <p:cNvPr id="1" name=""/>
@@ -3090,57 +3098,14 @@
       <p:grpSpPr/>
       <p:sp>
         <p:nvSpPr>
-          <p:cNvPr id="2" name="Rectangle 1"/>
-          <p:cNvSpPr/>
-          <p:nvPr/>
-        </p:nvSpPr>
-        <p:spPr>
-          <a:xfrm>
-            <a:off x="0" y="0"/>
-            <a:ext cx="12191695" cy="6858000"/>
-          </a:xfrm>
-          <a:prstGeom prst="rect">
-            <a:avLst/>
-          </a:prstGeom>
-          <a:solidFill>
-            <a:srgbClr val="0A0F1D"/>
-          </a:solidFill>
-          <a:ln>
-            <a:noFill/>
-          </a:ln>
-        </p:spPr>
-        <p:style>
-          <a:lnRef idx="1">
-            <a:schemeClr val="accent1"/>
-          </a:lnRef>
-          <a:fillRef idx="3">
-            <a:schemeClr val="accent1"/>
-          </a:fillRef>
-          <a:effectRef idx="2">
-            <a:schemeClr val="accent1"/>
-          </a:effectRef>
-          <a:fontRef idx="minor">
-            <a:schemeClr val="lt1"/>
-          </a:fontRef>
-        </p:style>
-        <p:txBody>
-          <a:bodyPr rtlCol="0" anchor="ctr"/>
-          <a:lstStyle/>
-          <a:p>
-            <a:pPr algn="ctr"/>
-          </a:p>
-        </p:txBody>
-      </p:sp>
-      <p:sp>
-        <p:nvSpPr>
-          <p:cNvPr id="3" name="TextBox 2"/>
+          <p:cNvPr id="2" name="TextBox 1"/>
           <p:cNvSpPr txBox="1"/>
           <p:nvPr/>
         </p:nvSpPr>
         <p:spPr>
           <a:xfrm>
             <a:off x="731520" y="365760"/>
-            <a:ext cx="10698480" cy="914400"/>
+            <a:ext cx="10698480" cy="1005840"/>
           </a:xfrm>
           <a:prstGeom prst="rect">
             <a:avLst/>
@@ -3148,7 +3113,7 @@
           <a:noFill/>
         </p:spPr>
         <p:txBody>
-          <a:bodyPr wrap="none">
+          <a:bodyPr wrap="square">
             <a:spAutoFit/>
           </a:bodyPr>
           <a:lstStyle/>
@@ -3165,18 +3130,31 @@
               <a:t>PRANA-TWIN System Architecture Diagram</a:t>
             </a:r>
           </a:p>
-        </p:txBody>
-      </p:sp>
-      <p:sp>
-        <p:nvSpPr>
-          <p:cNvPr id="4" name="Rounded Rectangle 3"/>
+          <a:p>
+            <a:pPr>
+              <a:defRPr sz="1300">
+                <a:solidFill>
+                  <a:srgbClr val="94A3B8"/>
+                </a:solidFill>
+                <a:latin typeface="Arial"/>
+              </a:defRPr>
+            </a:pPr>
+            <a:r>
+              <a:t>Multi-Stream Data Fusion, Compartmental ODEs, Ensemble ML Predictors, and Doctor Decision Support UI</a:t>
+            </a:r>
+          </a:p>
+        </p:txBody>
+      </p:sp>
+      <p:sp>
+        <p:nvSpPr>
+          <p:cNvPr id="3" name="Rounded Rectangle 2"/>
           <p:cNvSpPr/>
           <p:nvPr/>
         </p:nvSpPr>
         <p:spPr>
           <a:xfrm>
-            <a:off x="731520" y="1463040"/>
-            <a:ext cx="3291840" cy="4389120"/>
+            <a:off x="731520" y="1554480"/>
+            <a:ext cx="3291840" cy="4663440"/>
           </a:xfrm>
           <a:prstGeom prst="roundRect">
             <a:avLst/>
@@ -3214,14 +3192,14 @@
       </p:sp>
       <p:sp>
         <p:nvSpPr>
-          <p:cNvPr id="5" name="TextBox 4"/>
+          <p:cNvPr id="4" name="TextBox 3"/>
           <p:cNvSpPr txBox="1"/>
           <p:nvPr/>
         </p:nvSpPr>
         <p:spPr>
           <a:xfrm>
-            <a:off x="914400" y="1645920"/>
-            <a:ext cx="2926080" cy="4023360"/>
+            <a:off x="914400" y="1737360"/>
+            <a:ext cx="2926080" cy="4297680"/>
           </a:xfrm>
           <a:prstGeom prst="rect">
             <a:avLst/>
@@ -3262,7 +3240,7 @@
               </a:defRPr>
             </a:pPr>
             <a:r>
-              <a:t>▶  Static EHR: Demographics, HbA1c (8.6%), eGFR, Lipids, Meds</a:t>
+              <a:t>▶  Static EHR Stream: Demographics, HbA1c (8.6%), eGFR, Lipids, Prescriptions</a:t>
             </a:r>
           </a:p>
           <a:p>
@@ -3278,7 +3256,7 @@
               </a:defRPr>
             </a:pPr>
             <a:r>
-              <a:t>▶  Dynamic IoT: 5-min CGM Glucose, PPG Pulse, HRV (RMSSD), Steps</a:t>
+              <a:t>▶  Dynamic IoT Stream: 5-min CGM Glucose, PPG Pulse, HRV (RMSSD), Steps</a:t>
             </a:r>
           </a:p>
           <a:p>
@@ -3294,21 +3272,53 @@
               </a:defRPr>
             </a:pPr>
             <a:r>
-              <a:t>▶  Indian Dietary Profile: High-GI staple meal carbs (Rice, Parathas)</a:t>
-            </a:r>
-          </a:p>
-        </p:txBody>
-      </p:sp>
-      <p:sp>
-        <p:nvSpPr>
-          <p:cNvPr id="6" name="Rounded Rectangle 5"/>
+              <a:t>▶  Indian Dietary Profile: High-GI staple meal carb bolus (Rice, Parathas, Sweets)</a:t>
+            </a:r>
+          </a:p>
+          <a:p>
+            <a:pPr>
+              <a:spcAft>
+                <a:spcPts val="800"/>
+              </a:spcAft>
+              <a:defRPr sz="1100">
+                <a:solidFill>
+                  <a:srgbClr val="F1F5F9"/>
+                </a:solidFill>
+                <a:latin typeface="Arial"/>
+              </a:defRPr>
+            </a:pPr>
+            <a:r>
+              <a:t>▶  Circadian Telemetry: Nighttime fasting epochs &amp; autonomic sleep staging</a:t>
+            </a:r>
+          </a:p>
+          <a:p>
+            <a:pPr>
+              <a:spcAft>
+                <a:spcPts val="800"/>
+              </a:spcAft>
+              <a:defRPr sz="1100">
+                <a:solidFill>
+                  <a:srgbClr val="F1F5F9"/>
+                </a:solidFill>
+                <a:latin typeface="Arial"/>
+              </a:defRPr>
+            </a:pPr>
+            <a:r>
+              <a:t>▶  Real-time Validation: Quality-checked telemetry streams ingested asynchronously</a:t>
+            </a:r>
+          </a:p>
+        </p:txBody>
+      </p:sp>
+      <p:sp>
+        <p:nvSpPr>
+          <p:cNvPr id="5" name="Rounded Rectangle 4"/>
           <p:cNvSpPr/>
           <p:nvPr/>
         </p:nvSpPr>
         <p:spPr>
           <a:xfrm>
-            <a:off x="4389120" y="1463040"/>
-            <a:ext cx="3474720" cy="4389120"/>
+            <a:off x="4389120" y="1554480"/>
+            <a:ext cx="3474720" cy="4663440"/>
           </a:xfrm>
           <a:prstGeom prst="roundRect">
             <a:avLst/>
@@ -3346,14 +3356,14 @@
       </p:sp>
       <p:sp>
         <p:nvSpPr>
-          <p:cNvPr id="7" name="TextBox 6"/>
+          <p:cNvPr id="6" name="TextBox 5"/>
           <p:cNvSpPr txBox="1"/>
           <p:nvPr/>
         </p:nvSpPr>
         <p:spPr>
           <a:xfrm>
-            <a:off x="4572000" y="1645920"/>
-            <a:ext cx="3108960" cy="4023360"/>
+            <a:off x="4572000" y="1737360"/>
+            <a:ext cx="3108960" cy="4297680"/>
           </a:xfrm>
           <a:prstGeom prst="rect">
             <a:avLst/>
@@ -3394,7 +3404,7 @@
               </a:defRPr>
             </a:pPr>
             <a:r>
-              <a:t>▶  Physiological Compartment ODEs (Bergman Minimal Model)</a:t>
+              <a:t>▶  Physiological ODEs: Bergman Minimal Model (Plasma Glucose + Remote Insulin)</a:t>
             </a:r>
           </a:p>
           <a:p>
@@ -3410,7 +3420,7 @@
               </a:defRPr>
             </a:pPr>
             <a:r>
-              <a:t>▶  Multimodal Fusion Engine &amp; Temporal Derivative Extractor (dG/dt)</a:t>
+              <a:t>▶  Multimodal Feature Fusion: Temporal derivative extractor (dG/dt, d2G/dt2)</a:t>
             </a:r>
           </a:p>
           <a:p>
@@ -3426,7 +3436,7 @@
               </a:defRPr>
             </a:pPr>
             <a:r>
-              <a:t>▶  Gradient Boosted Regressor (120-min forward trajectory)</a:t>
+              <a:t>▶  Forward Horizon Regressor: Gradient Boosted 24-step trajectory (0-120 mins)</a:t>
             </a:r>
           </a:p>
           <a:p>
@@ -3442,7 +3452,7 @@
               </a:defRPr>
             </a:pPr>
             <a:r>
-              <a:t>▶  Adverse Event Classifiers (Spike &gt;220 mg/dL &amp; Hypo &lt;70 mg/dL)</a:t>
+              <a:t>▶  Adverse Event Classifiers: Acute Spike (&gt;220 mg/dL) &amp; Nocturnal Hypo (&lt;70 mg/dL)</a:t>
             </a:r>
           </a:p>
           <a:p>
@@ -3458,21 +3468,37 @@
               </a:defRPr>
             </a:pPr>
             <a:r>
-              <a:t>▶  Counterfactual 'What-If' Simulation Sandbox Engine</a:t>
-            </a:r>
-          </a:p>
-        </p:txBody>
-      </p:sp>
-      <p:sp>
-        <p:nvSpPr>
-          <p:cNvPr id="8" name="Rounded Rectangle 7"/>
+              <a:t>▶  Counterfactual Sandbox Engine: Instant simulation of Diet, Walk &amp; Meds</a:t>
+            </a:r>
+          </a:p>
+          <a:p>
+            <a:pPr>
+              <a:spcAft>
+                <a:spcPts val="800"/>
+              </a:spcAft>
+              <a:defRPr sz="1100">
+                <a:solidFill>
+                  <a:srgbClr val="F1F5F9"/>
+                </a:solidFill>
+                <a:latin typeface="Arial"/>
+              </a:defRPr>
+            </a:pPr>
+            <a:r>
+              <a:t>▶  Explainable AI (XAI): Dynamic attribution weights for clinical drivers</a:t>
+            </a:r>
+          </a:p>
+        </p:txBody>
+      </p:sp>
+      <p:sp>
+        <p:nvSpPr>
+          <p:cNvPr id="7" name="Rounded Rectangle 6"/>
           <p:cNvSpPr/>
           <p:nvPr/>
         </p:nvSpPr>
         <p:spPr>
           <a:xfrm>
-            <a:off x="8138160" y="1463040"/>
-            <a:ext cx="3291840" cy="4389120"/>
+            <a:off x="8138160" y="1554480"/>
+            <a:ext cx="3291840" cy="4663440"/>
           </a:xfrm>
           <a:prstGeom prst="roundRect">
             <a:avLst/>
@@ -3510,14 +3536,14 @@
       </p:sp>
       <p:sp>
         <p:nvSpPr>
-          <p:cNvPr id="9" name="TextBox 8"/>
+          <p:cNvPr id="8" name="TextBox 7"/>
           <p:cNvSpPr txBox="1"/>
           <p:nvPr/>
         </p:nvSpPr>
         <p:spPr>
           <a:xfrm>
-            <a:off x="8321040" y="1645920"/>
-            <a:ext cx="2926080" cy="4023360"/>
+            <a:off x="8321040" y="1737360"/>
+            <a:ext cx="2926080" cy="4297680"/>
           </a:xfrm>
           <a:prstGeom prst="rect">
             <a:avLst/>
@@ -3558,7 +3584,7 @@
               </a:defRPr>
             </a:pPr>
             <a:r>
-              <a:t>▶  Patient Triage Selector (Critical, High Risk, Moderate, Stable)</a:t>
+              <a:t>▶  Patient Triage Selector: Real-time risk status (Critical, High Risk, Moderate, Stable)</a:t>
             </a:r>
           </a:p>
           <a:p>
@@ -3574,7 +3600,7 @@
               </a:defRPr>
             </a:pPr>
             <a:r>
-              <a:t>▶  Interactive Virtual Human Organ Twin (Pancreas, Heart, Kidney, Liver)</a:t>
+              <a:t>▶  Interactive Organ Twin: SVG avatar with glowing Pancreas, Heart, Kidneys, Liver</a:t>
             </a:r>
           </a:p>
           <a:p>
@@ -3590,7 +3616,7 @@
               </a:defRPr>
             </a:pPr>
             <a:r>
-              <a:t>▶  2-Hour Forward Horizon Graph with 90% Confidence Bands</a:t>
+              <a:t>▶  2-Hour Predictive Chart: Horizon graph with 90% confidence bands &amp; thresholds</a:t>
             </a:r>
           </a:p>
           <a:p>
@@ -3606,7 +3632,7 @@
               </a:defRPr>
             </a:pPr>
             <a:r>
-              <a:t>▶  Counterfactual Sandbox (Sliders for Carbs, Walk, Meds)</a:t>
+              <a:t>▶  Counterfactual Sliders: Dynamic carb titration, walking minutes, and medication</a:t>
             </a:r>
           </a:p>
           <a:p>
@@ -3622,7 +3648,7 @@
               </a:defRPr>
             </a:pPr>
             <a:r>
-              <a:t>▶  One-Click RSSDI / ICMR Clinical Audit &amp; Ambulatory Glucose Report</a:t>
+              <a:t>▶  RSSDI / ICMR Clinical Audit: Instant export of AGP metrics &amp; consultation notes</a:t>
             </a:r>
           </a:p>
         </p:txBody>

</xml_diff>